<commit_message>
Added Participation and Sources to Report and Added pdf version of Report and PP
</commit_message>
<xml_diff>
--- a/Presentation/Closest Pair Presentation.pptx
+++ b/Presentation/Closest Pair Presentation.pptx
@@ -6835,7 +6835,7 @@
           <a:lstStyle/>
           <a:p>
             <a:r>
-              <a:rPr lang="en-US"/>
+              <a:rPr lang="en-US" dirty="0"/>
               <a:t>Reflection</a:t>
             </a:r>
           </a:p>
@@ -6893,7 +6893,7 @@
         </p:blipFill>
         <p:spPr>
           <a:xfrm>
-            <a:off x="6773642" y="2556387"/>
+            <a:off x="6705613" y="2562728"/>
             <a:ext cx="4839039" cy="3195484"/>
           </a:xfrm>
           <a:prstGeom prst="rect">
@@ -6903,10 +6903,10 @@
       </p:pic>
       <p:sp>
         <p:nvSpPr>
-          <p:cNvPr id="4" name="TextBox 3">
-            <a:extLst>
-              <a:ext uri="{FF2B5EF4-FFF2-40B4-BE49-F238E27FC236}">
-                <a16:creationId xmlns:a16="http://schemas.microsoft.com/office/drawing/2014/main" id="{9137D99A-CC7C-2BED-2C00-209A82B8B11E}"/>
+          <p:cNvPr id="8" name="TextBox 7">
+            <a:extLst>
+              <a:ext uri="{FF2B5EF4-FFF2-40B4-BE49-F238E27FC236}">
+                <a16:creationId xmlns:a16="http://schemas.microsoft.com/office/drawing/2014/main" id="{27890855-CB99-FB1D-23E4-AFA481F3F888}"/>
               </a:ext>
             </a:extLst>
           </p:cNvPr>
@@ -6915,8 +6915,8 @@
         </p:nvSpPr>
         <p:spPr>
           <a:xfrm>
-            <a:off x="753241" y="2767724"/>
-            <a:ext cx="2743200" cy="365760"/>
+            <a:off x="647348" y="2586533"/>
+            <a:ext cx="5750993" cy="3385542"/>
           </a:xfrm>
           <a:prstGeom prst="rect">
             <a:avLst/>
@@ -6932,53 +6932,17 @@
           </a:bodyPr>
           <a:lstStyle/>
           <a:p>
-            <a:pPr algn="l"/>
-            <a:endParaRPr lang="en-US"/>
-          </a:p>
-        </p:txBody>
-      </p:sp>
-      <p:sp>
-        <p:nvSpPr>
-          <p:cNvPr id="8" name="TextBox 7">
-            <a:extLst>
-              <a:ext uri="{FF2B5EF4-FFF2-40B4-BE49-F238E27FC236}">
-                <a16:creationId xmlns:a16="http://schemas.microsoft.com/office/drawing/2014/main" id="{27890855-CB99-FB1D-23E4-AFA481F3F888}"/>
-              </a:ext>
-            </a:extLst>
-          </p:cNvPr>
-          <p:cNvSpPr txBox="1"/>
-          <p:nvPr/>
-        </p:nvSpPr>
-        <p:spPr>
-          <a:xfrm>
-            <a:off x="1030121" y="2474050"/>
-            <a:ext cx="5750993" cy="3816429"/>
-          </a:xfrm>
-          <a:prstGeom prst="rect">
-            <a:avLst/>
-          </a:prstGeom>
-          <a:noFill/>
-        </p:spPr>
-        <p:txBody>
-          <a:bodyPr rot="0" spcFirstLastPara="0" vertOverflow="overflow" horzOverflow="overflow" vert="horz" wrap="square" lIns="91440" tIns="45720" rIns="91440" bIns="45720" numCol="1" spcCol="0" rtlCol="0" fromWordArt="0" anchor="t" anchorCtr="0" forceAA="0" compatLnSpc="1">
-            <a:prstTxWarp prst="textNoShape">
-              <a:avLst/>
-            </a:prstTxWarp>
-            <a:spAutoFit/>
-          </a:bodyPr>
-          <a:lstStyle/>
-          <a:p>
             <a:pPr marL="285750" indent="-285750">
               <a:buFont typeface="Arial"/>
               <a:buChar char="•"/>
             </a:pPr>
             <a:r>
-              <a:rPr lang="en-US" sz="2800">
+              <a:rPr lang="en-US" sz="2800" dirty="0">
                 <a:solidFill>
                   <a:schemeClr val="bg1"/>
                 </a:solidFill>
               </a:rPr>
-              <a:t>Decided to generate datasets instead of finding real life dataset</a:t>
+              <a:t>Deciding to generate datasets</a:t>
             </a:r>
           </a:p>
           <a:p>
@@ -6987,12 +6951,12 @@
               <a:buChar char="•"/>
             </a:pPr>
             <a:r>
-              <a:rPr lang="en-US" sz="2800">
+              <a:rPr lang="en-US" sz="2800" dirty="0">
                 <a:solidFill>
                   <a:schemeClr val="bg1"/>
                 </a:solidFill>
               </a:rPr>
-              <a:t>Seeing the differences between the result BCO got and what the actual closest pair was, and how that changed with iteration size</a:t>
+              <a:t>Seeing the differences between the result BCO got and what the actual closest pair was, and how that changed (n = 256)</a:t>
             </a:r>
           </a:p>
           <a:p>
@@ -7001,7 +6965,7 @@
               <a:buChar char="•"/>
             </a:pPr>
             <a:r>
-              <a:rPr lang="en-US" sz="2800">
+              <a:rPr lang="en-US" sz="2800" dirty="0">
                 <a:solidFill>
                   <a:schemeClr val="bg1"/>
                 </a:solidFill>
@@ -7274,7 +7238,7 @@
           <a:lstStyle/>
           <a:p>
             <a:r>
-              <a:rPr lang="en-US"/>
+              <a:rPr lang="en-US" dirty="0"/>
               <a:t>What is the Closest Pair Problem?</a:t>
             </a:r>
           </a:p>
@@ -7382,7 +7346,7 @@
           <a:lstStyle/>
           <a:p>
             <a:r>
-              <a:rPr lang="en-US" sz="2400">
+              <a:rPr lang="en-US" sz="2400" dirty="0">
                 <a:solidFill>
                   <a:srgbClr val="000000"/>
                 </a:solidFill>
@@ -7393,7 +7357,7 @@
             </a:r>
           </a:p>
           <a:p>
-            <a:endParaRPr lang="en-US" sz="2400">
+            <a:endParaRPr lang="en-US" sz="2400" dirty="0">
               <a:solidFill>
                 <a:srgbClr val="000000"/>
               </a:solidFill>
@@ -7401,7 +7365,7 @@
           </a:p>
           <a:p>
             <a:r>
-              <a:rPr lang="en-US" sz="2400">
+              <a:rPr lang="en-US" sz="2400" dirty="0">
                 <a:solidFill>
                   <a:srgbClr val="000000"/>
                 </a:solidFill>
@@ -7415,7 +7379,7 @@
               <a:buChar char="•"/>
             </a:pPr>
             <a:r>
-              <a:rPr lang="en-US" sz="2400">
+              <a:rPr lang="en-US" sz="2400" dirty="0">
                 <a:solidFill>
                   <a:srgbClr val="000000"/>
                 </a:solidFill>
@@ -7429,7 +7393,7 @@
               <a:buChar char="•"/>
             </a:pPr>
             <a:r>
-              <a:rPr lang="en-US" sz="2400">
+              <a:rPr lang="en-US" sz="2400" dirty="0">
                 <a:solidFill>
                   <a:srgbClr val="000000"/>
                 </a:solidFill>
@@ -7443,7 +7407,7 @@
               <a:buChar char="•"/>
             </a:pPr>
             <a:r>
-              <a:rPr lang="en-US" sz="2400">
+              <a:rPr lang="en-US" sz="2400" dirty="0">
                 <a:solidFill>
                   <a:srgbClr val="000000"/>
                 </a:solidFill>
@@ -7457,7 +7421,7 @@
               <a:buChar char="•"/>
             </a:pPr>
             <a:r>
-              <a:rPr lang="en-US" sz="2400">
+              <a:rPr lang="en-US" sz="2400" dirty="0">
                 <a:solidFill>
                   <a:srgbClr val="000000"/>
                 </a:solidFill>
@@ -7466,7 +7430,7 @@
             </a:r>
           </a:p>
           <a:p>
-            <a:endParaRPr lang="en-US" sz="2400">
+            <a:endParaRPr lang="en-US" sz="2400" dirty="0">
               <a:solidFill>
                 <a:srgbClr val="000000"/>
               </a:solidFill>
@@ -7823,7 +7787,7 @@
               <a:buChar char="•"/>
             </a:pPr>
             <a:r>
-              <a:rPr lang="en-US">
+              <a:rPr lang="en-US" dirty="0">
                 <a:highlight>
                   <a:srgbClr val="FFFFFF"/>
                 </a:highlight>
@@ -7832,7 +7796,7 @@
               </a:rPr>
               <a:t>How does runtime grow for each algorithm as input size 𝑛 increases</a:t>
             </a:r>
-            <a:endParaRPr lang="en-US">
+            <a:endParaRPr lang="en-US" dirty="0">
               <a:highlight>
                 <a:srgbClr val="606060"/>
               </a:highlight>
@@ -7846,7 +7810,7 @@
               <a:buChar char="•"/>
             </a:pPr>
             <a:r>
-              <a:rPr lang="en-US">
+              <a:rPr lang="en-US" dirty="0">
                 <a:highlight>
                   <a:srgbClr val="FFFFFF"/>
                 </a:highlight>
@@ -7855,7 +7819,7 @@
               </a:rPr>
               <a:t>At what input size does Divide &amp; Conquer outperform Brute Force</a:t>
             </a:r>
-            <a:endParaRPr lang="en-US">
+            <a:endParaRPr lang="en-US" dirty="0">
               <a:highlight>
                 <a:srgbClr val="606060"/>
               </a:highlight>
@@ -7869,7 +7833,7 @@
               <a:buChar char="•"/>
             </a:pPr>
             <a:r>
-              <a:rPr lang="en-US">
+              <a:rPr lang="en-US" dirty="0">
                 <a:highlight>
                   <a:srgbClr val="FFFFFF"/>
                 </a:highlight>
@@ -7878,7 +7842,7 @@
               </a:rPr>
               <a:t>Which algorithm is best for solving the closest pair problem</a:t>
             </a:r>
-            <a:endParaRPr lang="en-US" sz="2600">
+            <a:endParaRPr lang="en-US" sz="2600" dirty="0">
               <a:highlight>
                 <a:srgbClr val="FFFFFF"/>
               </a:highlight>
@@ -7890,7 +7854,7 @@
             <a:pPr marL="0" indent="0">
               <a:buNone/>
             </a:pPr>
-            <a:endParaRPr lang="en-US" sz="2400">
+            <a:endParaRPr lang="en-US" sz="2400" dirty="0">
               <a:latin typeface="Arial Nova"/>
             </a:endParaRPr>
           </a:p>
@@ -8183,7 +8147,7 @@
               <a:buNone/>
             </a:pPr>
             <a:r>
-              <a:rPr lang="en-US">
+              <a:rPr lang="en-US" dirty="0">
                 <a:ea typeface="+mn-lt"/>
                 <a:cs typeface="+mn-lt"/>
               </a:rPr>
@@ -8195,11 +8159,11 @@
               <a:buNone/>
             </a:pPr>
             <a:r>
-              <a:rPr lang="en-US"/>
+              <a:rPr lang="en-US" dirty="0"/>
               <a:t>Time Complexity: </a:t>
             </a:r>
             <a:r>
-              <a:rPr lang="en-US">
+              <a:rPr lang="en-US" dirty="0">
                 <a:ea typeface="+mn-lt"/>
                 <a:cs typeface="+mn-lt"/>
               </a:rPr>
@@ -8211,7 +8175,7 @@
               <a:buNone/>
             </a:pPr>
             <a:r>
-              <a:rPr lang="en-US"/>
+              <a:rPr lang="en-US" dirty="0"/>
               <a:t>We have this algorithm as a baseline due to it being very straightforward</a:t>
             </a:r>
           </a:p>
@@ -8347,7 +8311,7 @@
               </a:spcBef>
             </a:pPr>
             <a:r>
-              <a:rPr lang="en-US" sz="2600">
+              <a:rPr lang="en-US" sz="2600" dirty="0">
                 <a:solidFill>
                   <a:schemeClr val="bg1"/>
                 </a:solidFill>
@@ -8356,7 +8320,7 @@
               </a:rPr>
               <a:t>Points are recursively divided into smaller groups. Minimum distance is calculated within each group. During the merging step, check for possible closer pairs across the dividing point.</a:t>
             </a:r>
-            <a:endParaRPr lang="en-US" sz="2600">
+            <a:endParaRPr lang="en-US" sz="2600" dirty="0">
               <a:solidFill>
                 <a:schemeClr val="bg1"/>
               </a:solidFill>
@@ -8371,7 +8335,7 @@
               <a:buChar char="•"/>
             </a:pPr>
             <a:r>
-              <a:rPr lang="en-US" sz="2600">
+              <a:rPr lang="en-US" sz="2600" dirty="0">
                 <a:solidFill>
                   <a:schemeClr val="bg1"/>
                 </a:solidFill>
@@ -8380,7 +8344,7 @@
               </a:rPr>
               <a:t>Time complexity: Θ (n log n)</a:t>
             </a:r>
-            <a:endParaRPr lang="en-US" sz="2600">
+            <a:endParaRPr lang="en-US" sz="2600" dirty="0">
               <a:solidFill>
                 <a:schemeClr val="bg1"/>
               </a:solidFill>
@@ -8395,7 +8359,7 @@
               <a:buChar char="•"/>
             </a:pPr>
             <a:r>
-              <a:rPr lang="en-US" sz="2600">
+              <a:rPr lang="en-US" sz="2600" dirty="0">
                 <a:solidFill>
                   <a:schemeClr val="bg1"/>
                 </a:solidFill>
@@ -8414,7 +8378,7 @@
               <a:buChar char="•"/>
             </a:pPr>
             <a:r>
-              <a:rPr lang="en-US" sz="2600">
+              <a:rPr lang="en-US" sz="2600" dirty="0">
                 <a:solidFill>
                   <a:schemeClr val="bg1"/>
                 </a:solidFill>
@@ -8423,14 +8387,14 @@
               </a:rPr>
               <a:t>More complex to understand and implement</a:t>
             </a:r>
-            <a:endParaRPr lang="en-US" sz="2600">
+            <a:endParaRPr lang="en-US" sz="2600" dirty="0">
               <a:solidFill>
                 <a:schemeClr val="bg1"/>
               </a:solidFill>
             </a:endParaRPr>
           </a:p>
           <a:p>
-            <a:endParaRPr lang="en-US">
+            <a:endParaRPr lang="en-US" dirty="0">
               <a:solidFill>
                 <a:schemeClr val="bg1"/>
               </a:solidFill>
@@ -8732,18 +8696,18 @@
               <a:buNone/>
             </a:pPr>
             <a:r>
-              <a:rPr lang="en-US"/>
+              <a:rPr lang="en-US" dirty="0"/>
               <a:t>Line Sweep </a:t>
             </a:r>
             <a:r>
-              <a:rPr lang="en-US">
+              <a:rPr lang="en-US" dirty="0">
                 <a:ea typeface="+mn-lt"/>
                 <a:cs typeface="+mn-lt"/>
               </a:rPr>
               <a:t>algorithm first sorts all points by x-coordinate and then processes them from left to right using a sweep line.</a:t>
             </a:r>
             <a:r>
-              <a:rPr lang="en-US"/>
+              <a:rPr lang="en-US" dirty="0"/>
               <a:t> </a:t>
             </a:r>
           </a:p>
@@ -8752,7 +8716,7 @@
               <a:buNone/>
             </a:pPr>
             <a:r>
-              <a:rPr lang="en-US"/>
+              <a:rPr lang="en-US" dirty="0"/>
               <a:t>Time Complexity: Θ(n log n)</a:t>
             </a:r>
           </a:p>
@@ -8761,7 +8725,7 @@
               <a:buNone/>
             </a:pPr>
             <a:r>
-              <a:rPr lang="en-US"/>
+              <a:rPr lang="en-US" dirty="0"/>
               <a:t>We have this algorithm because it is a specialized algorithm and is useful for comparisons with general algorithms</a:t>
             </a:r>
           </a:p>
@@ -8825,10 +8789,10 @@
           <a:lstStyle/>
           <a:p>
             <a:r>
-              <a:rPr lang="en-US"/>
+              <a:rPr lang="en-US" dirty="0"/>
               <a:t>Bee Colony Optimization</a:t>
             </a:r>
-            <a:endParaRPr lang="en-US" b="0"/>
+            <a:endParaRPr lang="en-US" b="0" dirty="0"/>
           </a:p>
         </p:txBody>
       </p:sp>
@@ -8881,8 +8845,8 @@
         </p:nvSpPr>
         <p:spPr>
           <a:xfrm>
-            <a:off x="1026242" y="2027903"/>
-            <a:ext cx="9100984" cy="3672800"/>
+            <a:off x="1026243" y="2027903"/>
+            <a:ext cx="8711591" cy="3672800"/>
           </a:xfrm>
           <a:prstGeom prst="rect">
             <a:avLst/>
@@ -8898,162 +8862,166 @@
           </a:bodyPr>
           <a:lstStyle/>
           <a:p>
-            <a:pPr marL="0" lvl="1" algn="l" rtl="0">
+            <a:pPr marL="0" lvl="1">
               <a:spcBef>
                 <a:spcPts val="500"/>
               </a:spcBef>
             </a:pPr>
             <a:r>
-              <a:rPr lang="en-US" sz="2400" b="0" i="0">
+              <a:rPr lang="en-US" sz="2400" b="0" i="0" dirty="0">
                 <a:solidFill>
                   <a:schemeClr val="bg1"/>
                 </a:solidFill>
-                <a:latin typeface="Aptos"/>
                 <a:ea typeface="Aptos"/>
                 <a:cs typeface="Aptos"/>
               </a:rPr>
-              <a:t>Employed Bees: explore the neighborhood of their assigned source to find better, closer pairs</a:t>
-            </a:r>
-            <a:endParaRPr lang="en-US"/>
-          </a:p>
-          <a:p>
-            <a:pPr marL="0" lvl="1" algn="l" rtl="0">
+              <a:t>Employed Bees: </a:t>
+            </a:r>
+            <a:r>
+              <a:rPr lang="en-US" sz="2400" dirty="0">
+                <a:solidFill>
+                  <a:schemeClr val="bg1"/>
+                </a:solidFill>
+              </a:rPr>
+              <a:t>takes the current pair and compares it to a neighboring pair, keeping the closer one</a:t>
+            </a:r>
+          </a:p>
+          <a:p>
+            <a:pPr marL="0" lvl="1">
               <a:spcBef>
                 <a:spcPts val="500"/>
               </a:spcBef>
             </a:pPr>
             <a:r>
-              <a:rPr lang="en-US" sz="2400" b="0" i="0">
+              <a:rPr lang="en-US" sz="2400" b="0" i="0" dirty="0">
                 <a:solidFill>
                   <a:schemeClr val="bg1"/>
                 </a:solidFill>
-                <a:latin typeface="Aptos"/>
                 <a:ea typeface="Aptos"/>
                 <a:cs typeface="Aptos"/>
               </a:rPr>
               <a:t>Onlooker Bees: </a:t>
             </a:r>
             <a:r>
-              <a:rPr lang="en-US" sz="2400">
+              <a:rPr lang="en-US" sz="2400" dirty="0">
                 <a:solidFill>
                   <a:schemeClr val="bg1"/>
                 </a:solidFill>
-                <a:latin typeface="Aptos"/>
-                <a:ea typeface="Aptos"/>
-                <a:cs typeface="Aptos"/>
               </a:rPr>
-              <a:t>wait</a:t>
-            </a:r>
-            <a:r>
-              <a:rPr lang="en-US" sz="2400" b="0" i="0">
-                <a:solidFill>
-                  <a:schemeClr val="bg1"/>
-                </a:solidFill>
-                <a:latin typeface="Aptos"/>
-                <a:ea typeface="Aptos"/>
-                <a:cs typeface="Aptos"/>
-              </a:rPr>
-              <a:t> in the hive and choose a food source to exploit based on the information shared by employed bees</a:t>
-            </a:r>
-            <a:endParaRPr sz="2400" b="0" i="0" dirty="0">
-              <a:solidFill>
-                <a:schemeClr val="bg1"/>
-              </a:solidFill>
-              <a:latin typeface="Aptos"/>
-              <a:ea typeface="Aptos"/>
-              <a:cs typeface="Aptos"/>
-            </a:endParaRPr>
-          </a:p>
-          <a:p>
-            <a:pPr marL="0" lvl="1" algn="l" rtl="0">
+              <a:t>computes fitness for pairs and randomly picks a promising pair to attempt to find a closer distance</a:t>
+            </a:r>
+          </a:p>
+          <a:p>
+            <a:pPr marL="0" lvl="1">
               <a:spcBef>
                 <a:spcPts val="500"/>
               </a:spcBef>
             </a:pPr>
             <a:r>
-              <a:rPr lang="en-US" sz="2400" b="0" i="0">
+              <a:rPr lang="en-US" sz="2400" b="0" i="0" dirty="0">
                 <a:solidFill>
                   <a:schemeClr val="bg1"/>
                 </a:solidFill>
-                <a:latin typeface="Aptos"/>
                 <a:ea typeface="Aptos"/>
                 <a:cs typeface="Aptos"/>
               </a:rPr>
-              <a:t>Scout Bees: If a solution cannot be improved over a set number of cycles ("limit"), the employed bee abandons it and becomes a scout, searching for a new random pair of points</a:t>
-            </a:r>
-            <a:r>
-              <a:rPr sz="2400" b="0" i="0" dirty="0">
+              <a:t>Scout Bees: </a:t>
+            </a:r>
+            <a:r>
+              <a:rPr lang="en-US" sz="2400" dirty="0">
                 <a:solidFill>
                   <a:schemeClr val="bg1"/>
                 </a:solidFill>
-                <a:latin typeface="Aptos"/>
-                <a:ea typeface="Aptos"/>
-                <a:cs typeface="Aptos"/>
               </a:rPr>
-              <a:t> </a:t>
-            </a:r>
-          </a:p>
-          <a:p>
-            <a:pPr marL="228600" lvl="1" indent="-228600">
+              <a:t>determines that if the pair hasn’t improved after a specific number of iterations, then it may be a bad candidate and replaces the pair with a random pair</a:t>
+            </a:r>
+          </a:p>
+          <a:p>
+            <a:pPr marL="342900" lvl="1" indent="-342900">
               <a:spcBef>
                 <a:spcPts val="500"/>
               </a:spcBef>
-              <a:buFont typeface="Symbol"/>
+              <a:buFont typeface="Arial" panose="020B0604020202020204" pitchFamily="34" charset="0"/>
               <a:buChar char="•"/>
             </a:pPr>
             <a:r>
-              <a:rPr lang="en-US" sz="2400">
+              <a:rPr lang="en-US" sz="2400" dirty="0">
                 <a:solidFill>
                   <a:schemeClr val="bg1"/>
                 </a:solidFill>
-                <a:latin typeface="Aptos"/>
                 <a:ea typeface="Aptos"/>
                 <a:cs typeface="Aptos"/>
               </a:rPr>
               <a:t>Time Complexity: </a:t>
             </a:r>
             <a:r>
-              <a:rPr lang="en-US" sz="2400">
+              <a:rPr lang="en-US" sz="2400" dirty="0">
                 <a:solidFill>
                   <a:schemeClr val="bg1"/>
                 </a:solidFill>
-                <a:latin typeface="Aptos"/>
                 <a:ea typeface="+mn-lt"/>
                 <a:cs typeface="+mn-lt"/>
               </a:rPr>
-              <a:t>Θ (N⋅D⋅I) </a:t>
-            </a:r>
-          </a:p>
-          <a:p>
-            <a:pPr marL="228600" lvl="1" indent="-228600">
+              <a:t>Θ (N⋅I) </a:t>
+            </a:r>
+          </a:p>
+          <a:p>
+            <a:pPr marL="342900" lvl="1" indent="-342900">
               <a:spcBef>
                 <a:spcPts val="500"/>
               </a:spcBef>
-              <a:buFont typeface="Symbol"/>
+              <a:buFont typeface="Arial" panose="020B0604020202020204" pitchFamily="34" charset="0"/>
               <a:buChar char="•"/>
             </a:pPr>
             <a:r>
-              <a:rPr lang="en-US" sz="2400">
+              <a:rPr lang="en-US" sz="2400" dirty="0">
                 <a:solidFill>
                   <a:schemeClr val="bg1"/>
                 </a:solidFill>
-                <a:latin typeface="Aptos"/>
                 <a:ea typeface="Aptos"/>
                 <a:cs typeface="Aptos"/>
               </a:rPr>
               <a:t>Heuristic</a:t>
             </a:r>
-            <a:endParaRPr lang="en-US" sz="2400" dirty="0">
-              <a:solidFill>
-                <a:schemeClr val="bg1"/>
-              </a:solidFill>
-              <a:latin typeface="Aptos"/>
-              <a:ea typeface="Aptos"/>
-              <a:cs typeface="Aptos"/>
-            </a:endParaRPr>
-          </a:p>
-        </p:txBody>
-      </p:sp>
+          </a:p>
+        </p:txBody>
+      </p:sp>
+      <p:pic>
+        <p:nvPicPr>
+          <p:cNvPr id="3" name="Graphic 2" descr="Bee with solid fill">
+            <a:extLst>
+              <a:ext uri="{FF2B5EF4-FFF2-40B4-BE49-F238E27FC236}">
+                <a16:creationId xmlns:a16="http://schemas.microsoft.com/office/drawing/2014/main" id="{F86B3D8F-D801-537C-C5DA-BDD616F4A41B}"/>
+              </a:ext>
+            </a:extLst>
+          </p:cNvPr>
+          <p:cNvPicPr>
+            <a:picLocks noChangeAspect="1"/>
+          </p:cNvPicPr>
+          <p:nvPr/>
+        </p:nvPicPr>
+        <p:blipFill>
+          <a:blip>
+            <a:extLst>
+              <a:ext uri="{96DAC541-7B7A-43D3-8B79-37D633B846F1}">
+                <asvg:svgBlip xmlns:asvg="http://schemas.microsoft.com/office/drawing/2016/SVG/main" r:embed="rId3"/>
+              </a:ext>
+            </a:extLst>
+          </a:blip>
+          <a:stretch>
+            <a:fillRect/>
+          </a:stretch>
+        </p:blipFill>
+        <p:spPr>
+          <a:xfrm rot="2243993">
+            <a:off x="7822728" y="812955"/>
+            <a:ext cx="914400" cy="914400"/>
+          </a:xfrm>
+          <a:prstGeom prst="rect">
+            <a:avLst/>
+          </a:prstGeom>
+        </p:spPr>
+      </p:pic>
     </p:spTree>
     <p:extLst>
       <p:ext uri="{BB962C8B-B14F-4D97-AF65-F5344CB8AC3E}">
@@ -10274,12 +10242,12 @@
 </file>
 
 <file path=customXml/item1.xml><?xml version="1.0" encoding="utf-8"?>
-<?mso-contentType ?>
-<FormTemplates xmlns="http://schemas.microsoft.com/sharepoint/v3/contenttype/forms">
-  <Display>DocumentLibraryForm</Display>
-  <Edit>DocumentLibraryForm</Edit>
-  <New>DocumentLibraryForm</New>
-</FormTemplates>
+<p:properties xmlns:p="http://schemas.microsoft.com/office/2006/metadata/properties" xmlns:xsi="http://www.w3.org/2001/XMLSchema-instance" xmlns:pc="http://schemas.microsoft.com/office/infopath/2007/PartnerControls">
+  <documentManagement>
+    <Status xmlns="71af3243-3dd4-4a8d-8c0d-dd76da1f02a5">Not started</Status>
+    <MediaServiceKeyPoints xmlns="71af3243-3dd4-4a8d-8c0d-dd76da1f02a5" xsi:nil="true"/>
+  </documentManagement>
+</p:properties>
 </file>
 
 <file path=customXml/item2.xml><?xml version="1.0" encoding="utf-8"?>
@@ -10504,18 +10472,20 @@
 </file>
 
 <file path=customXml/item3.xml><?xml version="1.0" encoding="utf-8"?>
-<p:properties xmlns:p="http://schemas.microsoft.com/office/2006/metadata/properties" xmlns:xsi="http://www.w3.org/2001/XMLSchema-instance" xmlns:pc="http://schemas.microsoft.com/office/infopath/2007/PartnerControls">
-  <documentManagement>
-    <Status xmlns="71af3243-3dd4-4a8d-8c0d-dd76da1f02a5">Not started</Status>
-    <MediaServiceKeyPoints xmlns="71af3243-3dd4-4a8d-8c0d-dd76da1f02a5" xsi:nil="true"/>
-  </documentManagement>
-</p:properties>
+<?mso-contentType ?>
+<FormTemplates xmlns="http://schemas.microsoft.com/sharepoint/v3/contenttype/forms">
+  <Display>DocumentLibraryForm</Display>
+  <Edit>DocumentLibraryForm</Edit>
+  <New>DocumentLibraryForm</New>
+</FormTemplates>
 </file>
 
 <file path=customXml/itemProps1.xml><?xml version="1.0" encoding="utf-8"?>
-<ds:datastoreItem xmlns:ds="http://schemas.openxmlformats.org/officeDocument/2006/customXml" ds:itemID="{3149A8C3-21EC-4C35-871F-CCC7148089A3}">
+<ds:datastoreItem xmlns:ds="http://schemas.openxmlformats.org/officeDocument/2006/customXml" ds:itemID="{081B53F0-FE0E-4C4C-84FF-93580062270A}">
   <ds:schemaRefs>
-    <ds:schemaRef ds:uri="http://schemas.microsoft.com/sharepoint/v3/contenttype/forms"/>
+    <ds:schemaRef ds:uri="71af3243-3dd4-4a8d-8c0d-dd76da1f02a5"/>
+    <ds:schemaRef ds:uri="http://schemas.microsoft.com/office/2006/metadata/properties"/>
+    <ds:schemaRef ds:uri="http://schemas.microsoft.com/office/infopath/2007/PartnerControls"/>
   </ds:schemaRefs>
 </ds:datastoreItem>
 </file>
@@ -10540,11 +10510,9 @@
 </file>
 
 <file path=customXml/itemProps3.xml><?xml version="1.0" encoding="utf-8"?>
-<ds:datastoreItem xmlns:ds="http://schemas.openxmlformats.org/officeDocument/2006/customXml" ds:itemID="{081B53F0-FE0E-4C4C-84FF-93580062270A}">
+<ds:datastoreItem xmlns:ds="http://schemas.openxmlformats.org/officeDocument/2006/customXml" ds:itemID="{3149A8C3-21EC-4C35-871F-CCC7148089A3}">
   <ds:schemaRefs>
-    <ds:schemaRef ds:uri="71af3243-3dd4-4a8d-8c0d-dd76da1f02a5"/>
-    <ds:schemaRef ds:uri="http://schemas.microsoft.com/office/2006/metadata/properties"/>
-    <ds:schemaRef ds:uri="http://schemas.microsoft.com/office/infopath/2007/PartnerControls"/>
+    <ds:schemaRef ds:uri="http://schemas.microsoft.com/sharepoint/v3/contenttype/forms"/>
   </ds:schemaRefs>
 </ds:datastoreItem>
 </file>
</xml_diff>

<commit_message>
Added more pictures to powerpoint
</commit_message>
<xml_diff>
--- a/Presentation/Closest Pair Presentation.pptx
+++ b/Presentation/Closest Pair Presentation.pptx
@@ -5,7 +5,7 @@
     <p:sldMasterId id="2147483658" r:id="rId4"/>
   </p:sldMasterIdLst>
   <p:notesMasterIdLst>
-    <p:notesMasterId r:id="rId20"/>
+    <p:notesMasterId r:id="rId19"/>
   </p:notesMasterIdLst>
   <p:sldIdLst>
     <p:sldId id="335" r:id="rId5"/>
@@ -14,15 +14,14 @@
     <p:sldId id="347" r:id="rId8"/>
     <p:sldId id="321" r:id="rId9"/>
     <p:sldId id="359" r:id="rId10"/>
-    <p:sldId id="358" r:id="rId11"/>
+    <p:sldId id="361" r:id="rId11"/>
     <p:sldId id="354" r:id="rId12"/>
     <p:sldId id="348" r:id="rId13"/>
     <p:sldId id="356" r:id="rId14"/>
     <p:sldId id="352" r:id="rId15"/>
     <p:sldId id="355" r:id="rId16"/>
     <p:sldId id="360" r:id="rId17"/>
-    <p:sldId id="353" r:id="rId18"/>
-    <p:sldId id="357" r:id="rId19"/>
+    <p:sldId id="357" r:id="rId18"/>
   </p:sldIdLst>
   <p:sldSz cx="12192000" cy="6858000"/>
   <p:notesSz cx="6858000" cy="9144000"/>
@@ -145,71 +144,14 @@
   <p1510:revLst>
     <p1510:client id="{159EAA75-9301-6605-33B0-7BBE3DC54370}" v="179" dt="2026-04-26T23:16:48.263"/>
     <p1510:client id="{4CAFC20C-9398-5EE9-8FEF-47138E417A0B}" v="742" dt="2026-04-27T13:54:33.124"/>
-    <p1510:client id="{851AA497-DC9E-4400-9384-9CFB3E09F321}" v="1" dt="2026-04-27T18:53:56.200"/>
+    <p1510:client id="{7C2E27DB-AA57-6929-AC0E-619842E6F3B0}" v="1" dt="2026-04-25T15:00:22.658"/>
     <p1510:client id="{85ED6188-1819-3FB3-DE9F-C1D50D28FE64}" v="235" dt="2026-04-27T12:00:18.444"/>
+    <p1510:client id="{8C286DA6-DE91-24CE-470B-26462603E72D}" v="244" dt="2026-04-25T14:23:35.680"/>
+    <p1510:client id="{8F6E97CC-DAEF-9645-F307-215A6030A4BB}" v="586" dt="2026-04-25T22:45:03.043"/>
+    <p1510:client id="{A55696EC-85F4-0C17-1336-CD219567A23A}" v="210" dt="2026-04-25T20:51:22.103"/>
+    <p1510:client id="{AFA95628-C784-3A2B-9925-3E56671444EE}" v="345" dt="2026-04-25T15:00:06.903"/>
   </p1510:revLst>
 </p1510:revInfo>
-</file>
-
-<file path=ppt/changesInfos/changesInfo1.xml><?xml version="1.0" encoding="utf-8"?>
-<pc:chgInfo xmlns:a="http://schemas.openxmlformats.org/drawingml/2006/main" xmlns:r="http://schemas.openxmlformats.org/officeDocument/2006/relationships" xmlns:ac="http://schemas.microsoft.com/office/drawing/2013/main/command" xmlns:pc="http://schemas.microsoft.com/office/powerpoint/2013/main/command">
-  <pc:docChgLst>
-    <pc:chgData name="Sydney F" userId="1b1a22377a5e92eb" providerId="LiveId" clId="{953DCEB0-9295-4200-8A9D-D426C90B077A}"/>
-    <pc:docChg chg="custSel addSld modSld">
-      <pc:chgData name="Sydney F" userId="1b1a22377a5e92eb" providerId="LiveId" clId="{953DCEB0-9295-4200-8A9D-D426C90B077A}" dt="2026-04-27T18:54:09.698" v="21" actId="478"/>
-      <pc:docMkLst>
-        <pc:docMk/>
-      </pc:docMkLst>
-      <pc:sldChg chg="addSp delSp modSp new mod">
-        <pc:chgData name="Sydney F" userId="1b1a22377a5e92eb" providerId="LiveId" clId="{953DCEB0-9295-4200-8A9D-D426C90B077A}" dt="2026-04-27T18:54:09.698" v="21" actId="478"/>
-        <pc:sldMkLst>
-          <pc:docMk/>
-          <pc:sldMk cId="2435647483" sldId="360"/>
-        </pc:sldMkLst>
-        <pc:spChg chg="del">
-          <ac:chgData name="Sydney F" userId="1b1a22377a5e92eb" providerId="LiveId" clId="{953DCEB0-9295-4200-8A9D-D426C90B077A}" dt="2026-04-27T18:53:06.237" v="2" actId="478"/>
-          <ac:spMkLst>
-            <pc:docMk/>
-            <pc:sldMk cId="2435647483" sldId="360"/>
-            <ac:spMk id="2" creationId="{5E9C98D6-7368-B8FC-B55C-31F3E6E7F336}"/>
-          </ac:spMkLst>
-        </pc:spChg>
-        <pc:spChg chg="mod">
-          <ac:chgData name="Sydney F" userId="1b1a22377a5e92eb" providerId="LiveId" clId="{953DCEB0-9295-4200-8A9D-D426C90B077A}" dt="2026-04-27T18:53:39.898" v="17" actId="20577"/>
-          <ac:spMkLst>
-            <pc:docMk/>
-            <pc:sldMk cId="2435647483" sldId="360"/>
-            <ac:spMk id="3" creationId="{5CC851C4-ACBD-5CD5-C4E2-6619058B9448}"/>
-          </ac:spMkLst>
-        </pc:spChg>
-        <pc:spChg chg="del">
-          <ac:chgData name="Sydney F" userId="1b1a22377a5e92eb" providerId="LiveId" clId="{953DCEB0-9295-4200-8A9D-D426C90B077A}" dt="2026-04-27T18:54:09.698" v="21" actId="478"/>
-          <ac:spMkLst>
-            <pc:docMk/>
-            <pc:sldMk cId="2435647483" sldId="360"/>
-            <ac:spMk id="4" creationId="{A8832890-ECDF-9B75-D8C0-C50FB8C026D5}"/>
-          </ac:spMkLst>
-        </pc:spChg>
-        <pc:spChg chg="del">
-          <ac:chgData name="Sydney F" userId="1b1a22377a5e92eb" providerId="LiveId" clId="{953DCEB0-9295-4200-8A9D-D426C90B077A}" dt="2026-04-27T18:54:07.516" v="20" actId="478"/>
-          <ac:spMkLst>
-            <pc:docMk/>
-            <pc:sldMk cId="2435647483" sldId="360"/>
-            <ac:spMk id="5" creationId="{406B90B8-CEC7-4483-8AAF-FDEDBD267C9D}"/>
-          </ac:spMkLst>
-        </pc:spChg>
-        <pc:spChg chg="add mod">
-          <ac:chgData name="Sydney F" userId="1b1a22377a5e92eb" providerId="LiveId" clId="{953DCEB0-9295-4200-8A9D-D426C90B077A}" dt="2026-04-27T18:53:45.813" v="19" actId="20577"/>
-          <ac:spMkLst>
-            <pc:docMk/>
-            <pc:sldMk cId="2435647483" sldId="360"/>
-            <ac:spMk id="8" creationId="{0EB9F5D8-5386-5F74-459B-CC15CEAE4236}"/>
-          </ac:spMkLst>
-        </pc:spChg>
-      </pc:sldChg>
-    </pc:docChg>
-  </pc:docChgLst>
-</pc:chgInfo>
 </file>
 
 <file path=ppt/notesMasters/notesMaster1.xml><?xml version="1.0" encoding="utf-8"?>
@@ -294,7 +236,7 @@
           <a:p>
             <a:fld id="{6EE7A52F-9D89-7442-A8E9-48D1527B5F6B}" type="datetimeFigureOut">
               <a:rPr lang="en-US" smtClean="0"/>
-              <a:t>4/27/2026</a:t>
+              <a:t>4/29/2026</a:t>
             </a:fld>
             <a:endParaRPr lang="en-US"/>
           </a:p>
@@ -589,13 +531,6 @@
           </p:nvPr>
         </p:nvSpPr>
         <p:spPr/>
-        <p:txBody>
-          <a:bodyPr/>
-          <a:lstStyle/>
-          <a:p>
-            <a:endParaRPr lang="en-US"/>
-          </a:p>
-        </p:txBody>
       </p:sp>
       <p:sp>
         <p:nvSpPr>
@@ -643,121 +578,6 @@
     <p:extLst>
       <p:ext uri="{BB962C8B-B14F-4D97-AF65-F5344CB8AC3E}">
         <p14:creationId xmlns:p14="http://schemas.microsoft.com/office/powerpoint/2010/main" val="1373397985"/>
-      </p:ext>
-    </p:extLst>
-  </p:cSld>
-  <p:clrMapOvr>
-    <a:masterClrMapping/>
-  </p:clrMapOvr>
-</p:notes>
-</file>
-
-<file path=ppt/notesSlides/notesSlide2.xml><?xml version="1.0" encoding="utf-8"?>
-<p:notes xmlns:a="http://schemas.openxmlformats.org/drawingml/2006/main" xmlns:r="http://schemas.openxmlformats.org/officeDocument/2006/relationships" xmlns:p="http://schemas.openxmlformats.org/presentationml/2006/main">
-  <p:cSld>
-    <p:spTree>
-      <p:nvGrpSpPr>
-        <p:cNvPr id="1" name="">
-          <a:extLst>
-            <a:ext uri="{FF2B5EF4-FFF2-40B4-BE49-F238E27FC236}">
-              <a16:creationId xmlns:a16="http://schemas.microsoft.com/office/drawing/2014/main" id="{EE8DA2A6-DB86-9EF3-A63C-1B28C4E74008}"/>
-            </a:ext>
-          </a:extLst>
-        </p:cNvPr>
-        <p:cNvGrpSpPr/>
-        <p:nvPr/>
-      </p:nvGrpSpPr>
-      <p:grpSpPr>
-        <a:xfrm>
-          <a:off x="0" y="0"/>
-          <a:ext cx="0" cy="0"/>
-          <a:chOff x="0" y="0"/>
-          <a:chExt cx="0" cy="0"/>
-        </a:xfrm>
-      </p:grpSpPr>
-      <p:sp>
-        <p:nvSpPr>
-          <p:cNvPr id="2" name="Slide Image Placeholder 1">
-            <a:extLst>
-              <a:ext uri="{FF2B5EF4-FFF2-40B4-BE49-F238E27FC236}">
-                <a16:creationId xmlns:a16="http://schemas.microsoft.com/office/drawing/2014/main" id="{1BB532A8-2283-A90E-AFD0-291A794C9822}"/>
-              </a:ext>
-            </a:extLst>
-          </p:cNvPr>
-          <p:cNvSpPr>
-            <a:spLocks noGrp="1" noRot="1" noChangeAspect="1"/>
-          </p:cNvSpPr>
-          <p:nvPr>
-            <p:ph type="sldImg"/>
-          </p:nvPr>
-        </p:nvSpPr>
-        <p:spPr/>
-        <p:txBody>
-          <a:bodyPr/>
-          <a:lstStyle/>
-          <a:p>
-            <a:endParaRPr lang="en-US"/>
-          </a:p>
-        </p:txBody>
-      </p:sp>
-      <p:sp>
-        <p:nvSpPr>
-          <p:cNvPr id="3" name="Notes Placeholder 2">
-            <a:extLst>
-              <a:ext uri="{FF2B5EF4-FFF2-40B4-BE49-F238E27FC236}">
-                <a16:creationId xmlns:a16="http://schemas.microsoft.com/office/drawing/2014/main" id="{03DFE80A-884B-6B6C-7F12-8FB77913423E}"/>
-              </a:ext>
-            </a:extLst>
-          </p:cNvPr>
-          <p:cNvSpPr>
-            <a:spLocks noGrp="1"/>
-          </p:cNvSpPr>
-          <p:nvPr>
-            <p:ph type="body" idx="1"/>
-          </p:nvPr>
-        </p:nvSpPr>
-        <p:spPr/>
-        <p:txBody>
-          <a:bodyPr/>
-          <a:lstStyle/>
-          <a:p>
-            <a:endParaRPr lang="en-US"/>
-          </a:p>
-        </p:txBody>
-      </p:sp>
-      <p:sp>
-        <p:nvSpPr>
-          <p:cNvPr id="4" name="Slide Number Placeholder 3">
-            <a:extLst>
-              <a:ext uri="{FF2B5EF4-FFF2-40B4-BE49-F238E27FC236}">
-                <a16:creationId xmlns:a16="http://schemas.microsoft.com/office/drawing/2014/main" id="{C9D94ED8-3510-1F21-4184-60F642248024}"/>
-              </a:ext>
-            </a:extLst>
-          </p:cNvPr>
-          <p:cNvSpPr>
-            <a:spLocks noGrp="1"/>
-          </p:cNvSpPr>
-          <p:nvPr>
-            <p:ph type="sldNum" sz="quarter" idx="5"/>
-          </p:nvPr>
-        </p:nvSpPr>
-        <p:spPr/>
-        <p:txBody>
-          <a:bodyPr/>
-          <a:lstStyle/>
-          <a:p>
-            <a:fld id="{A89C7E07-3C67-C64C-8DA0-0404F6303970}" type="slidenum">
-              <a:rPr lang="en-US" smtClean="0"/>
-              <a:t>7</a:t>
-            </a:fld>
-            <a:endParaRPr lang="en-US"/>
-          </a:p>
-        </p:txBody>
-      </p:sp>
-    </p:spTree>
-    <p:extLst>
-      <p:ext uri="{BB962C8B-B14F-4D97-AF65-F5344CB8AC3E}">
-        <p14:creationId xmlns:p14="http://schemas.microsoft.com/office/powerpoint/2010/main" val="1062529120"/>
       </p:ext>
     </p:extLst>
   </p:cSld>
@@ -6365,7 +6185,7 @@
           <a:lstStyle/>
           <a:p>
             <a:r>
-              <a:rPr lang="en-US"/>
+              <a:rPr lang="en-US" dirty="0"/>
               <a:t>Closest Pair Problem</a:t>
             </a:r>
           </a:p>
@@ -6387,19 +6207,24 @@
             <p:ph sz="quarter" idx="11"/>
           </p:nvPr>
         </p:nvSpPr>
-        <p:spPr/>
+        <p:spPr>
+          <a:xfrm>
+            <a:off x="1194179" y="4722380"/>
+            <a:ext cx="7806047" cy="281164"/>
+          </a:xfrm>
+        </p:spPr>
         <p:txBody>
           <a:bodyPr lIns="0" tIns="0" rIns="0" bIns="0" anchor="t"/>
           <a:lstStyle/>
           <a:p>
             <a:r>
-              <a:rPr lang="en-US" b="1"/>
+              <a:rPr lang="en-US" sz="2200" b="1" dirty="0"/>
               <a:t>Lydia Ballard, Sydney Frisbee</a:t>
             </a:r>
-            <a:endParaRPr lang="en-US"/>
-          </a:p>
-          <a:p>
-            <a:endParaRPr lang="en-US"/>
+            <a:endParaRPr lang="en-US" sz="2200" dirty="0"/>
+          </a:p>
+          <a:p>
+            <a:endParaRPr lang="en-US" dirty="0"/>
           </a:p>
         </p:txBody>
       </p:sp>
@@ -6771,7 +6596,7 @@
           <a:lstStyle/>
           <a:p>
             <a:r>
-              <a:rPr lang="en-US" sz="2600">
+              <a:rPr lang="en-US" sz="2600" dirty="0">
                 <a:solidFill>
                   <a:srgbClr val="000000"/>
                 </a:solidFill>
@@ -6783,7 +6608,7 @@
           </a:p>
           <a:p>
             <a:pPr algn="l"/>
-            <a:endParaRPr lang="en-US" sz="2600">
+            <a:endParaRPr lang="en-US" sz="2600" dirty="0">
               <a:solidFill>
                 <a:srgbClr val="000000"/>
               </a:solidFill>
@@ -6793,7 +6618,7 @@
           </a:p>
           <a:p>
             <a:r>
-              <a:rPr lang="en-US" sz="2600">
+              <a:rPr lang="en-US" sz="2600" dirty="0">
                 <a:solidFill>
                   <a:srgbClr val="000000"/>
                 </a:solidFill>
@@ -6802,14 +6627,14 @@
               </a:rPr>
               <a:t>Divide and Conquer becomes much faster than Brute Force as input size increases, showing the impact of better time complexity. Divide and Conquer specifically gets better at n = 16.</a:t>
             </a:r>
-            <a:endParaRPr lang="en-US" sz="2600">
+            <a:endParaRPr lang="en-US" sz="2600" dirty="0">
               <a:solidFill>
                 <a:srgbClr val="000000"/>
               </a:solidFill>
             </a:endParaRPr>
           </a:p>
           <a:p>
-            <a:endParaRPr lang="en-US" sz="2600">
+            <a:endParaRPr lang="en-US" sz="2600" dirty="0">
               <a:solidFill>
                 <a:srgbClr val="000000"/>
               </a:solidFill>
@@ -6819,18 +6644,18 @@
           </a:p>
           <a:p>
             <a:r>
-              <a:rPr lang="en-US" sz="2600">
+              <a:rPr lang="en-US" sz="2600" dirty="0">
                 <a:solidFill>
                   <a:srgbClr val="000000"/>
                 </a:solidFill>
                 <a:ea typeface="+mn-lt"/>
                 <a:cs typeface="+mn-lt"/>
               </a:rPr>
-              <a:t>With our data, we can conclude that Line Sweep is the best algorithm to solve the Closest Pair problem.</a:t>
-            </a:r>
-          </a:p>
-          <a:p>
-            <a:endParaRPr lang="en-US" sz="2400">
+              <a:t>With our data, we can conclude that Line Sweep is the most time efficient algorithm to solve the Closest Pair problem.</a:t>
+            </a:r>
+          </a:p>
+          <a:p>
+            <a:endParaRPr lang="en-US" sz="2400" dirty="0">
               <a:solidFill>
                 <a:srgbClr val="000000"/>
               </a:solidFill>
@@ -6839,7 +6664,7 @@
             </a:endParaRPr>
           </a:p>
           <a:p>
-            <a:endParaRPr lang="en-US" sz="2400">
+            <a:endParaRPr lang="en-US" sz="2400" dirty="0">
               <a:solidFill>
                 <a:srgbClr val="000000"/>
               </a:solidFill>
@@ -7160,8 +6985,8 @@
         </p:nvSpPr>
         <p:spPr>
           <a:xfrm>
-            <a:off x="1028699" y="2006959"/>
-            <a:ext cx="9756531" cy="2750561"/>
+            <a:off x="1028700" y="2363518"/>
+            <a:ext cx="9535783" cy="2786789"/>
           </a:xfrm>
           <a:prstGeom prst="rect">
             <a:avLst/>
@@ -7173,6 +6998,132 @@
             <a:spAutoFit/>
           </a:bodyPr>
           <a:lstStyle/>
+          <a:p>
+            <a:pPr>
+              <a:lnSpc>
+                <a:spcPct val="150000"/>
+              </a:lnSpc>
+              <a:spcAft>
+                <a:spcPts val="800"/>
+              </a:spcAft>
+            </a:pPr>
+            <a:r>
+              <a:rPr lang="en-US" sz="1200" dirty="0">
+                <a:solidFill>
+                  <a:schemeClr val="bg1"/>
+                </a:solidFill>
+                <a:effectLst/>
+                <a:latin typeface="+mj-lt"/>
+                <a:ea typeface="Malgun Gothic" panose="020B0503020000020004" pitchFamily="34" charset="-127"/>
+                <a:cs typeface="Times New Roman" panose="02020603050405020304" pitchFamily="18" charset="0"/>
+              </a:rPr>
+              <a:t>“Closest Pair of Points.” </a:t>
+            </a:r>
+            <a:r>
+              <a:rPr lang="en-US" sz="1200" i="1" dirty="0">
+                <a:solidFill>
+                  <a:schemeClr val="bg1"/>
+                </a:solidFill>
+                <a:effectLst/>
+                <a:latin typeface="+mj-lt"/>
+                <a:ea typeface="Malgun Gothic" panose="020B0503020000020004" pitchFamily="34" charset="-127"/>
+                <a:cs typeface="Times New Roman" panose="02020603050405020304" pitchFamily="18" charset="0"/>
+              </a:rPr>
+              <a:t>GeeksforGeeks</a:t>
+            </a:r>
+            <a:r>
+              <a:rPr lang="en-US" sz="1200" dirty="0">
+                <a:solidFill>
+                  <a:schemeClr val="bg1"/>
+                </a:solidFill>
+                <a:effectLst/>
+                <a:latin typeface="+mj-lt"/>
+                <a:ea typeface="Malgun Gothic" panose="020B0503020000020004" pitchFamily="34" charset="-127"/>
+                <a:cs typeface="Times New Roman" panose="02020603050405020304" pitchFamily="18" charset="0"/>
+              </a:rPr>
+              <a:t>, 21 Apr. 2026, </a:t>
+            </a:r>
+            <a:r>
+              <a:rPr lang="en-US" sz="1200" dirty="0">
+                <a:solidFill>
+                  <a:schemeClr val="bg1"/>
+                </a:solidFill>
+                <a:latin typeface="+mj-lt"/>
+                <a:ea typeface="Malgun Gothic" panose="020B0503020000020004" pitchFamily="34" charset="-127"/>
+                <a:cs typeface="Times New Roman" panose="02020603050405020304" pitchFamily="18" charset="0"/>
+              </a:rPr>
+              <a:t>https://www.geeksforgeeks.org/dsa/closest-pair-of-points-using-sweep-line-algorithm/ </a:t>
+            </a:r>
+          </a:p>
+          <a:p>
+            <a:pPr>
+              <a:lnSpc>
+                <a:spcPct val="150000"/>
+              </a:lnSpc>
+              <a:spcAft>
+                <a:spcPts val="800"/>
+              </a:spcAft>
+            </a:pPr>
+            <a:endParaRPr lang="en-US" sz="1200" dirty="0">
+              <a:solidFill>
+                <a:schemeClr val="bg1"/>
+              </a:solidFill>
+              <a:latin typeface="+mj-lt"/>
+              <a:ea typeface="Malgun Gothic" panose="020B0503020000020004" pitchFamily="34" charset="-127"/>
+              <a:cs typeface="Times New Roman" panose="02020603050405020304" pitchFamily="18" charset="0"/>
+            </a:endParaRPr>
+          </a:p>
+          <a:p>
+            <a:pPr>
+              <a:lnSpc>
+                <a:spcPct val="150000"/>
+              </a:lnSpc>
+              <a:spcAft>
+                <a:spcPts val="800"/>
+              </a:spcAft>
+            </a:pPr>
+            <a:r>
+              <a:rPr lang="en-US" sz="1200" dirty="0" err="1">
+                <a:solidFill>
+                  <a:schemeClr val="bg1"/>
+                </a:solidFill>
+                <a:latin typeface="+mj-lt"/>
+                <a:ea typeface="Malgun Gothic" panose="020B0503020000020004" pitchFamily="34" charset="-127"/>
+                <a:cs typeface="Times New Roman" panose="02020603050405020304" pitchFamily="18" charset="0"/>
+              </a:rPr>
+              <a:t>PhABC</a:t>
+            </a:r>
+            <a:r>
+              <a:rPr lang="en-US" sz="1200" dirty="0">
+                <a:solidFill>
+                  <a:schemeClr val="bg1"/>
+                </a:solidFill>
+                <a:latin typeface="+mj-lt"/>
+                <a:ea typeface="Malgun Gothic" panose="020B0503020000020004" pitchFamily="34" charset="-127"/>
+                <a:cs typeface="Times New Roman" panose="02020603050405020304" pitchFamily="18" charset="0"/>
+              </a:rPr>
+              <a:t>: A Hybrid Artificial Bee Colony Strategy for Pairwise test suite Generation with Constraints Support - Scientific Figure on ResearchGate. Available from: https://www.researchgate.net/figure/Flowchart-of-the-Artificial-Bee-Colony-algorithm_fig1_337512964</a:t>
+            </a:r>
+          </a:p>
+          <a:p>
+            <a:pPr>
+              <a:lnSpc>
+                <a:spcPct val="150000"/>
+              </a:lnSpc>
+              <a:spcAft>
+                <a:spcPts val="800"/>
+              </a:spcAft>
+            </a:pPr>
+            <a:endParaRPr lang="en-US" sz="1200" dirty="0">
+              <a:solidFill>
+                <a:schemeClr val="bg1"/>
+              </a:solidFill>
+              <a:effectLst/>
+              <a:latin typeface="+mj-lt"/>
+              <a:ea typeface="Malgun Gothic" panose="020B0503020000020004" pitchFamily="34" charset="-127"/>
+              <a:cs typeface="Times New Roman" panose="02020603050405020304" pitchFamily="18" charset="0"/>
+            </a:endParaRPr>
+          </a:p>
           <a:p>
             <a:pPr marL="0" marR="0">
               <a:lnSpc>
@@ -7184,40 +7135,16 @@
               <a:buNone/>
             </a:pPr>
             <a:r>
-              <a:rPr lang="en-US" sz="1800" dirty="0">
+              <a:rPr lang="en-US" sz="1200" dirty="0">
                 <a:solidFill>
                   <a:schemeClr val="bg1"/>
                 </a:solidFill>
                 <a:effectLst/>
-                <a:latin typeface="Aptos" panose="020B0004020202020204" pitchFamily="34" charset="0"/>
+                <a:latin typeface="+mj-lt"/>
                 <a:ea typeface="Malgun Gothic" panose="020B0503020000020004" pitchFamily="34" charset="-127"/>
                 <a:cs typeface="Times New Roman" panose="02020603050405020304" pitchFamily="18" charset="0"/>
               </a:rPr>
-              <a:t>“Closest Pair of Points.” </a:t>
-            </a:r>
-            <a:r>
-              <a:rPr lang="en-US" sz="1800" i="1" dirty="0">
-                <a:solidFill>
-                  <a:schemeClr val="bg1"/>
-                </a:solidFill>
-                <a:effectLst/>
-                <a:latin typeface="Aptos" panose="020B0004020202020204" pitchFamily="34" charset="0"/>
-                <a:ea typeface="Malgun Gothic" panose="020B0503020000020004" pitchFamily="34" charset="-127"/>
-                <a:cs typeface="Times New Roman" panose="02020603050405020304" pitchFamily="18" charset="0"/>
-              </a:rPr>
-              <a:t>GeeksforGeeks</a:t>
-            </a:r>
-            <a:r>
-              <a:rPr lang="en-US" sz="1800" dirty="0">
-                <a:solidFill>
-                  <a:schemeClr val="bg1"/>
-                </a:solidFill>
-                <a:effectLst/>
-                <a:latin typeface="Aptos" panose="020B0004020202020204" pitchFamily="34" charset="0"/>
-                <a:ea typeface="Malgun Gothic" panose="020B0503020000020004" pitchFamily="34" charset="-127"/>
-                <a:cs typeface="Times New Roman" panose="02020603050405020304" pitchFamily="18" charset="0"/>
-              </a:rPr>
-              <a:t>, 21 Apr. 2026, www.geeksforgeeks.org/dsa/closest-pair-of-points-using-divide-and-conquer-algorithm/.</a:t>
+              <a:t>“ChatGPT.” OpenAI, 2025, chat.openai.com/.</a:t>
             </a:r>
           </a:p>
           <a:p>
@@ -7231,35 +7158,12 @@
               <a:buNone/>
             </a:pPr>
             <a:r>
-              <a:rPr lang="en-US" sz="1800" dirty="0">
+              <a:rPr lang="en-US" sz="1200" dirty="0">
                 <a:solidFill>
                   <a:schemeClr val="bg1"/>
                 </a:solidFill>
                 <a:effectLst/>
-                <a:latin typeface="Aptos" panose="020B0004020202020204" pitchFamily="34" charset="0"/>
-                <a:ea typeface="Malgun Gothic" panose="020B0503020000020004" pitchFamily="34" charset="-127"/>
-                <a:cs typeface="Times New Roman" panose="02020603050405020304" pitchFamily="18" charset="0"/>
-              </a:rPr>
-              <a:t>“ChatGPT.” OpenAI, 2025, chat.openai.com/.</a:t>
-            </a:r>
-          </a:p>
-          <a:p>
-            <a:pPr marL="0" marR="0">
-              <a:lnSpc>
-                <a:spcPct val="150000"/>
-              </a:lnSpc>
-              <a:spcAft>
-                <a:spcPts val="800"/>
-              </a:spcAft>
-              <a:buNone/>
-            </a:pPr>
-            <a:r>
-              <a:rPr lang="en-US" sz="1800" dirty="0">
-                <a:solidFill>
-                  <a:schemeClr val="bg1"/>
-                </a:solidFill>
-                <a:effectLst/>
-                <a:latin typeface="Aptos" panose="020B0004020202020204" pitchFamily="34" charset="0"/>
+                <a:latin typeface="+mj-lt"/>
                 <a:ea typeface="Malgun Gothic" panose="020B0503020000020004" pitchFamily="34" charset="-127"/>
                 <a:cs typeface="Times New Roman" panose="02020603050405020304" pitchFamily="18" charset="0"/>
               </a:rPr>
@@ -7282,105 +7186,6 @@
 </file>
 
 <file path=ppt/slides/slide14.xml><?xml version="1.0" encoding="utf-8"?>
-<p:sld xmlns:a="http://schemas.openxmlformats.org/drawingml/2006/main" xmlns:r="http://schemas.openxmlformats.org/officeDocument/2006/relationships" xmlns:p="http://schemas.openxmlformats.org/presentationml/2006/main">
-  <p:cSld>
-    <p:spTree>
-      <p:nvGrpSpPr>
-        <p:cNvPr id="1" name=""/>
-        <p:cNvGrpSpPr/>
-        <p:nvPr/>
-      </p:nvGrpSpPr>
-      <p:grpSpPr>
-        <a:xfrm>
-          <a:off x="0" y="0"/>
-          <a:ext cx="0" cy="0"/>
-          <a:chOff x="0" y="0"/>
-          <a:chExt cx="0" cy="0"/>
-        </a:xfrm>
-      </p:grpSpPr>
-      <p:sp>
-        <p:nvSpPr>
-          <p:cNvPr id="5" name="Title 4">
-            <a:extLst>
-              <a:ext uri="{FF2B5EF4-FFF2-40B4-BE49-F238E27FC236}">
-                <a16:creationId xmlns:a16="http://schemas.microsoft.com/office/drawing/2014/main" id="{AD04CBC4-0243-204C-B5D8-F76B92BCD4CA}"/>
-              </a:ext>
-            </a:extLst>
-          </p:cNvPr>
-          <p:cNvSpPr>
-            <a:spLocks noGrp="1"/>
-          </p:cNvSpPr>
-          <p:nvPr>
-            <p:ph type="title"/>
-          </p:nvPr>
-        </p:nvSpPr>
-        <p:spPr>
-          <a:xfrm>
-            <a:off x="2185555" y="1068341"/>
-            <a:ext cx="7810500" cy="645284"/>
-          </a:xfrm>
-        </p:spPr>
-        <p:txBody>
-          <a:bodyPr/>
-          <a:lstStyle/>
-          <a:p>
-            <a:pPr algn="ctr"/>
-            <a:r>
-              <a:rPr lang="en-US"/>
-              <a:t>Questions</a:t>
-            </a:r>
-          </a:p>
-        </p:txBody>
-      </p:sp>
-      <p:sp>
-        <p:nvSpPr>
-          <p:cNvPr id="11" name="Slide Number Placeholder 10">
-            <a:extLst>
-              <a:ext uri="{FF2B5EF4-FFF2-40B4-BE49-F238E27FC236}">
-                <a16:creationId xmlns:a16="http://schemas.microsoft.com/office/drawing/2014/main" id="{00166BBA-67F2-4018-A96E-8101731B482D}"/>
-              </a:ext>
-            </a:extLst>
-          </p:cNvPr>
-          <p:cNvSpPr>
-            <a:spLocks noGrp="1"/>
-          </p:cNvSpPr>
-          <p:nvPr>
-            <p:ph type="sldNum" sz="quarter" idx="22"/>
-          </p:nvPr>
-        </p:nvSpPr>
-        <p:spPr>
-          <a:xfrm>
-            <a:off x="11493500" y="6292334"/>
-            <a:ext cx="412750" cy="182880"/>
-          </a:xfrm>
-        </p:spPr>
-        <p:txBody>
-          <a:bodyPr/>
-          <a:lstStyle/>
-          <a:p>
-            <a:fld id="{7782931A-7D25-4B4B-9464-57AE418934A3}" type="slidenum">
-              <a:rPr lang="en-US" smtClean="0"/>
-              <a:pPr/>
-              <a:t>14</a:t>
-            </a:fld>
-            <a:endParaRPr lang="en-US"/>
-          </a:p>
-        </p:txBody>
-      </p:sp>
-    </p:spTree>
-    <p:extLst>
-      <p:ext uri="{BB962C8B-B14F-4D97-AF65-F5344CB8AC3E}">
-        <p14:creationId xmlns:p14="http://schemas.microsoft.com/office/powerpoint/2010/main" val="3466443543"/>
-      </p:ext>
-    </p:extLst>
-  </p:cSld>
-  <p:clrMapOvr>
-    <a:masterClrMapping/>
-  </p:clrMapOvr>
-</p:sld>
-</file>
-
-<file path=ppt/slides/slide15.xml><?xml version="1.0" encoding="utf-8"?>
 <p:sld xmlns:a="http://schemas.openxmlformats.org/drawingml/2006/main" xmlns:r="http://schemas.openxmlformats.org/officeDocument/2006/relationships" xmlns:p="http://schemas.openxmlformats.org/presentationml/2006/main">
   <p:cSld>
     <p:spTree>
@@ -7433,10 +7238,10 @@
       </p:sp>
       <p:sp>
         <p:nvSpPr>
-          <p:cNvPr id="3" name="Content Placeholder 2">
-            <a:extLst>
-              <a:ext uri="{FF2B5EF4-FFF2-40B4-BE49-F238E27FC236}">
-                <a16:creationId xmlns:a16="http://schemas.microsoft.com/office/drawing/2014/main" id="{C6D36D37-8413-1D96-2C2E-64B350E03A5F}"/>
+          <p:cNvPr id="5" name="Content Placeholder 2">
+            <a:extLst>
+              <a:ext uri="{FF2B5EF4-FFF2-40B4-BE49-F238E27FC236}">
+                <a16:creationId xmlns:a16="http://schemas.microsoft.com/office/drawing/2014/main" id="{FBC967F4-2173-BC13-B0F4-0A101DD67674}"/>
               </a:ext>
             </a:extLst>
           </p:cNvPr>
@@ -7447,19 +7252,24 @@
             <p:ph sz="quarter" idx="11"/>
           </p:nvPr>
         </p:nvSpPr>
-        <p:spPr/>
+        <p:spPr>
+          <a:xfrm>
+            <a:off x="1194179" y="4722380"/>
+            <a:ext cx="7806047" cy="281164"/>
+          </a:xfrm>
+        </p:spPr>
         <p:txBody>
           <a:bodyPr lIns="0" tIns="0" rIns="0" bIns="0" anchor="t"/>
           <a:lstStyle/>
           <a:p>
             <a:r>
-              <a:rPr lang="en-US" b="1"/>
+              <a:rPr lang="en-US" sz="2200" b="1" dirty="0"/>
               <a:t>Lydia Ballard, Sydney Frisbee</a:t>
             </a:r>
-            <a:endParaRPr lang="en-US"/>
-          </a:p>
-          <a:p>
-            <a:endParaRPr lang="en-US"/>
+            <a:endParaRPr lang="en-US" sz="2200" dirty="0"/>
+          </a:p>
+          <a:p>
+            <a:endParaRPr lang="en-US" dirty="0"/>
           </a:p>
         </p:txBody>
       </p:sp>
@@ -8570,7 +8380,7 @@
         </p:nvSpPr>
         <p:spPr>
           <a:xfrm>
-            <a:off x="1030692" y="2141272"/>
+            <a:off x="973182" y="2187279"/>
             <a:ext cx="9444476" cy="3362459"/>
           </a:xfrm>
           <a:prstGeom prst="rect">
@@ -8800,8 +8610,8 @@
         </p:nvSpPr>
         <p:spPr>
           <a:xfrm>
-            <a:off x="1025878" y="2301522"/>
-            <a:ext cx="7810500" cy="2989263"/>
+            <a:off x="1028700" y="2311698"/>
+            <a:ext cx="5374922" cy="3696757"/>
           </a:xfrm>
           <a:prstGeom prst="rect">
             <a:avLst/>
@@ -8978,18 +8788,18 @@
               <a:buNone/>
             </a:pPr>
             <a:r>
-              <a:rPr lang="en-US" dirty="0"/>
+              <a:rPr lang="en-US" sz="2400" dirty="0"/>
               <a:t>Line Sweep </a:t>
             </a:r>
             <a:r>
-              <a:rPr lang="en-US" dirty="0">
+              <a:rPr lang="en-US" sz="2400" dirty="0">
                 <a:ea typeface="+mn-lt"/>
                 <a:cs typeface="+mn-lt"/>
               </a:rPr>
               <a:t>algorithm first sorts all points by x-coordinate and then processes them from left to right using a sweep line.</a:t>
             </a:r>
             <a:r>
-              <a:rPr lang="en-US" dirty="0"/>
+              <a:rPr lang="en-US" sz="2400" dirty="0"/>
               <a:t> </a:t>
             </a:r>
           </a:p>
@@ -8998,7 +8808,7 @@
               <a:buNone/>
             </a:pPr>
             <a:r>
-              <a:rPr lang="en-US" dirty="0"/>
+              <a:rPr lang="en-US" sz="2400" dirty="0"/>
               <a:t>Time Complexity: Θ(n log n)</a:t>
             </a:r>
           </a:p>
@@ -9007,12 +8817,62 @@
               <a:buNone/>
             </a:pPr>
             <a:r>
-              <a:rPr lang="en-US" dirty="0"/>
+              <a:rPr lang="en-US" sz="2400" dirty="0"/>
               <a:t>We have this algorithm because it is a specialized algorithm and is useful for comparisons with general algorithms</a:t>
             </a:r>
           </a:p>
         </p:txBody>
       </p:sp>
+      <p:pic>
+        <p:nvPicPr>
+          <p:cNvPr id="1026" name="Picture 2">
+            <a:extLst>
+              <a:ext uri="{FF2B5EF4-FFF2-40B4-BE49-F238E27FC236}">
+                <a16:creationId xmlns:a16="http://schemas.microsoft.com/office/drawing/2014/main" id="{1521BB62-1209-E9FC-E74F-015DAE2FD229}"/>
+              </a:ext>
+            </a:extLst>
+          </p:cNvPr>
+          <p:cNvPicPr>
+            <a:picLocks noChangeAspect="1" noChangeArrowheads="1"/>
+          </p:cNvPicPr>
+          <p:nvPr/>
+        </p:nvPicPr>
+        <p:blipFill rotWithShape="1">
+          <a:blip r:embed="rId2">
+            <a:extLst>
+              <a:ext uri="{28A0092B-C50C-407E-A947-70E740481C1C}">
+                <a14:useLocalDpi xmlns:a14="http://schemas.microsoft.com/office/drawing/2010/main" val="0"/>
+              </a:ext>
+            </a:extLst>
+          </a:blip>
+          <a:srcRect l="5706" t="16999" r="3144"/>
+          <a:stretch>
+            <a:fillRect/>
+          </a:stretch>
+        </p:blipFill>
+        <p:spPr bwMode="auto">
+          <a:xfrm>
+            <a:off x="6636587" y="2375139"/>
+            <a:ext cx="4226945" cy="2751930"/>
+          </a:xfrm>
+          <a:prstGeom prst="rect">
+            <a:avLst/>
+          </a:prstGeom>
+          <a:noFill/>
+          <a:ln>
+            <a:noFill/>
+          </a:ln>
+          <a:extLst>
+            <a:ext uri="{909E8E84-426E-40DD-AFC4-6F175D3DCCD1}">
+              <a14:hiddenFill xmlns:a14="http://schemas.microsoft.com/office/drawing/2010/main">
+                <a:solidFill>
+                  <a:srgbClr val="FFFFFF"/>
+                </a:solidFill>
+              </a14:hiddenFill>
+            </a:ext>
+          </a:extLst>
+        </p:spPr>
+      </p:pic>
     </p:spTree>
     <p:extLst>
       <p:ext uri="{BB962C8B-B14F-4D97-AF65-F5344CB8AC3E}">
@@ -9031,13 +8891,7 @@
   <p:cSld>
     <p:spTree>
       <p:nvGrpSpPr>
-        <p:cNvPr id="1" name="">
-          <a:extLst>
-            <a:ext uri="{FF2B5EF4-FFF2-40B4-BE49-F238E27FC236}">
-              <a16:creationId xmlns:a16="http://schemas.microsoft.com/office/drawing/2014/main" id="{117360B9-EDE8-D58C-D16A-352C7497A95C}"/>
-            </a:ext>
-          </a:extLst>
-        </p:cNvPr>
+        <p:cNvPr id="1" name=""/>
         <p:cNvGrpSpPr/>
         <p:nvPr/>
       </p:nvGrpSpPr>
@@ -9051,55 +8905,73 @@
       </p:grpSpPr>
       <p:sp>
         <p:nvSpPr>
-          <p:cNvPr id="4" name="Title 3">
-            <a:extLst>
-              <a:ext uri="{FF2B5EF4-FFF2-40B4-BE49-F238E27FC236}">
-                <a16:creationId xmlns:a16="http://schemas.microsoft.com/office/drawing/2014/main" id="{F3C8BDE0-08B2-EF1D-1F8C-AE98157C03B4}"/>
-              </a:ext>
-            </a:extLst>
-          </p:cNvPr>
-          <p:cNvSpPr>
-            <a:spLocks noGrp="1"/>
-          </p:cNvSpPr>
-          <p:nvPr>
-            <p:ph type="title"/>
+          <p:cNvPr id="17" name="Rectangle 16">
+            <a:extLst>
+              <a:ext uri="{FF2B5EF4-FFF2-40B4-BE49-F238E27FC236}">
+                <a16:creationId xmlns:a16="http://schemas.microsoft.com/office/drawing/2014/main" id="{E023D451-3147-8143-6885-0CB6A99FE918}"/>
+              </a:ext>
+            </a:extLst>
+          </p:cNvPr>
+          <p:cNvSpPr/>
+          <p:nvPr/>
+        </p:nvSpPr>
+        <p:spPr>
+          <a:xfrm>
+            <a:off x="7699587" y="1321710"/>
+            <a:ext cx="845389" cy="1213449"/>
+          </a:xfrm>
+          <a:prstGeom prst="rect">
+            <a:avLst/>
+          </a:prstGeom>
+          <a:solidFill>
+            <a:schemeClr val="accent2"/>
+          </a:solidFill>
+          <a:ln>
+            <a:noFill/>
+          </a:ln>
+        </p:spPr>
+        <p:style>
+          <a:lnRef idx="2">
+            <a:schemeClr val="accent1">
+              <a:shade val="15000"/>
+            </a:schemeClr>
+          </a:lnRef>
+          <a:fillRef idx="1">
+            <a:schemeClr val="accent1"/>
+          </a:fillRef>
+          <a:effectRef idx="0">
+            <a:schemeClr val="accent1"/>
+          </a:effectRef>
+          <a:fontRef idx="minor">
+            <a:schemeClr val="lt1"/>
+          </a:fontRef>
+        </p:style>
+        <p:txBody>
+          <a:bodyPr rtlCol="0" anchor="ctr"/>
+          <a:lstStyle/>
+          <a:p>
+            <a:pPr algn="ctr"/>
+            <a:endParaRPr lang="en-US"/>
+          </a:p>
+        </p:txBody>
+      </p:sp>
+      <p:sp>
+        <p:nvSpPr>
+          <p:cNvPr id="13" name="Slide Number Placeholder 12">
+            <a:extLst>
+              <a:ext uri="{FF2B5EF4-FFF2-40B4-BE49-F238E27FC236}">
+                <a16:creationId xmlns:a16="http://schemas.microsoft.com/office/drawing/2014/main" id="{964A3C67-EF06-D9B8-746E-327D8A8C3162}"/>
+              </a:ext>
+            </a:extLst>
+          </p:cNvPr>
+          <p:cNvSpPr>
+            <a:spLocks noGrp="1"/>
+          </p:cNvSpPr>
+          <p:nvPr>
+            <p:ph type="sldNum" sz="quarter" idx="28"/>
           </p:nvPr>
         </p:nvSpPr>
         <p:spPr/>
-        <p:txBody>
-          <a:bodyPr/>
-          <a:lstStyle/>
-          <a:p>
-            <a:r>
-              <a:rPr lang="en-US" dirty="0"/>
-              <a:t>Bee Colony Optimization</a:t>
-            </a:r>
-            <a:endParaRPr lang="en-US" b="0" dirty="0"/>
-          </a:p>
-        </p:txBody>
-      </p:sp>
-      <p:sp>
-        <p:nvSpPr>
-          <p:cNvPr id="5" name="Slide Number Placeholder 4">
-            <a:extLst>
-              <a:ext uri="{FF2B5EF4-FFF2-40B4-BE49-F238E27FC236}">
-                <a16:creationId xmlns:a16="http://schemas.microsoft.com/office/drawing/2014/main" id="{D55EE862-0882-61CB-867B-FE3FE30FF074}"/>
-              </a:ext>
-            </a:extLst>
-          </p:cNvPr>
-          <p:cNvSpPr>
-            <a:spLocks noGrp="1"/>
-          </p:cNvSpPr>
-          <p:nvPr>
-            <p:ph type="sldNum" sz="quarter" idx="13"/>
-          </p:nvPr>
-        </p:nvSpPr>
-        <p:spPr>
-          <a:xfrm>
-            <a:off x="11493500" y="6292334"/>
-            <a:ext cx="412750" cy="182880"/>
-          </a:xfrm>
-        </p:spPr>
         <p:txBody>
           <a:bodyPr/>
           <a:lstStyle/>
@@ -9115,10 +8987,44 @@
       </p:sp>
       <p:sp>
         <p:nvSpPr>
-          <p:cNvPr id="6" name="TextBox 5">
-            <a:extLst>
-              <a:ext uri="{FF2B5EF4-FFF2-40B4-BE49-F238E27FC236}">
-                <a16:creationId xmlns:a16="http://schemas.microsoft.com/office/drawing/2014/main" id="{60B70D2E-1DE3-E6C2-9ED4-131475FD4B1D}"/>
+          <p:cNvPr id="14" name="Title 3">
+            <a:extLst>
+              <a:ext uri="{FF2B5EF4-FFF2-40B4-BE49-F238E27FC236}">
+                <a16:creationId xmlns:a16="http://schemas.microsoft.com/office/drawing/2014/main" id="{C2FC2C51-9DD0-0575-49D5-FDE5B59557AC}"/>
+              </a:ext>
+            </a:extLst>
+          </p:cNvPr>
+          <p:cNvSpPr>
+            <a:spLocks noGrp="1"/>
+          </p:cNvSpPr>
+          <p:nvPr>
+            <p:ph type="title"/>
+          </p:nvPr>
+        </p:nvSpPr>
+        <p:spPr>
+          <a:xfrm>
+            <a:off x="1047750" y="999068"/>
+            <a:ext cx="10096500" cy="645284"/>
+          </a:xfrm>
+        </p:spPr>
+        <p:txBody>
+          <a:bodyPr/>
+          <a:lstStyle/>
+          <a:p>
+            <a:r>
+              <a:rPr lang="en-US" dirty="0"/>
+              <a:t>Bee Colony Optimization</a:t>
+            </a:r>
+            <a:endParaRPr lang="en-US" b="0" dirty="0"/>
+          </a:p>
+        </p:txBody>
+      </p:sp>
+      <p:sp>
+        <p:nvSpPr>
+          <p:cNvPr id="15" name="TextBox 14">
+            <a:extLst>
+              <a:ext uri="{FF2B5EF4-FFF2-40B4-BE49-F238E27FC236}">
+                <a16:creationId xmlns:a16="http://schemas.microsoft.com/office/drawing/2014/main" id="{1C57E67A-93B3-600A-A9DF-12DE78260E40}"/>
               </a:ext>
             </a:extLst>
           </p:cNvPr>
@@ -9127,8 +9033,8 @@
         </p:nvSpPr>
         <p:spPr>
           <a:xfrm>
-            <a:off x="1026243" y="2027903"/>
-            <a:ext cx="8711591" cy="3672800"/>
+            <a:off x="953145" y="2219424"/>
+            <a:ext cx="6841048" cy="4072910"/>
           </a:xfrm>
           <a:prstGeom prst="rect">
             <a:avLst/>
@@ -9150,7 +9056,7 @@
               </a:spcBef>
             </a:pPr>
             <a:r>
-              <a:rPr lang="en-US" sz="2400" b="0" i="0" dirty="0">
+              <a:rPr lang="en-US" sz="2200" b="0" i="0" dirty="0">
                 <a:solidFill>
                   <a:schemeClr val="bg1"/>
                 </a:solidFill>
@@ -9160,7 +9066,7 @@
               <a:t>Employed Bees: </a:t>
             </a:r>
             <a:r>
-              <a:rPr lang="en-US" sz="2400" dirty="0">
+              <a:rPr lang="en-US" sz="2200" dirty="0">
                 <a:solidFill>
                   <a:schemeClr val="bg1"/>
                 </a:solidFill>
@@ -9175,7 +9081,7 @@
               </a:spcBef>
             </a:pPr>
             <a:r>
-              <a:rPr lang="en-US" sz="2400" b="0" i="0" dirty="0">
+              <a:rPr lang="en-US" sz="2200" b="0" i="0" dirty="0">
                 <a:solidFill>
                   <a:schemeClr val="bg1"/>
                 </a:solidFill>
@@ -9185,7 +9091,7 @@
               <a:t>Onlooker Bees: </a:t>
             </a:r>
             <a:r>
-              <a:rPr lang="en-US" sz="2400" dirty="0">
+              <a:rPr lang="en-US" sz="2200" dirty="0">
                 <a:solidFill>
                   <a:schemeClr val="bg1"/>
                 </a:solidFill>
@@ -9200,7 +9106,7 @@
               </a:spcBef>
             </a:pPr>
             <a:r>
-              <a:rPr lang="en-US" sz="2400" b="0" i="0" dirty="0">
+              <a:rPr lang="en-US" sz="2200" b="0" i="0" dirty="0">
                 <a:solidFill>
                   <a:schemeClr val="bg1"/>
                 </a:solidFill>
@@ -9210,7 +9116,7 @@
               <a:t>Scout Bees: </a:t>
             </a:r>
             <a:r>
-              <a:rPr lang="en-US" sz="2400" dirty="0">
+              <a:rPr lang="en-US" sz="2200" dirty="0">
                 <a:solidFill>
                   <a:schemeClr val="bg1"/>
                 </a:solidFill>
@@ -9227,7 +9133,7 @@
               <a:buChar char="•"/>
             </a:pPr>
             <a:r>
-              <a:rPr lang="en-US" sz="2400" dirty="0">
+              <a:rPr lang="en-US" sz="2200" dirty="0">
                 <a:solidFill>
                   <a:schemeClr val="bg1"/>
                 </a:solidFill>
@@ -9237,7 +9143,7 @@
               <a:t>Time Complexity: </a:t>
             </a:r>
             <a:r>
-              <a:rPr lang="en-US" sz="2400" dirty="0">
+              <a:rPr lang="en-US" sz="2200" dirty="0">
                 <a:solidFill>
                   <a:schemeClr val="bg1"/>
                 </a:solidFill>
@@ -9256,7 +9162,7 @@
               <a:buChar char="•"/>
             </a:pPr>
             <a:r>
-              <a:rPr lang="en-US" sz="2400" dirty="0">
+              <a:rPr lang="en-US" sz="2200" dirty="0">
                 <a:solidFill>
                   <a:schemeClr val="bg1"/>
                 </a:solidFill>
@@ -9270,10 +9176,10 @@
       </p:sp>
       <p:pic>
         <p:nvPicPr>
-          <p:cNvPr id="3" name="Graphic 2" descr="Bee with solid fill">
-            <a:extLst>
-              <a:ext uri="{FF2B5EF4-FFF2-40B4-BE49-F238E27FC236}">
-                <a16:creationId xmlns:a16="http://schemas.microsoft.com/office/drawing/2014/main" id="{F86B3D8F-D801-537C-C5DA-BDD616F4A41B}"/>
+          <p:cNvPr id="16" name="Graphic 15" descr="Bee with solid fill">
+            <a:extLst>
+              <a:ext uri="{FF2B5EF4-FFF2-40B4-BE49-F238E27FC236}">
+                <a16:creationId xmlns:a16="http://schemas.microsoft.com/office/drawing/2014/main" id="{BDB17D76-259F-5489-BF84-FB32D8728FFF}"/>
               </a:ext>
             </a:extLst>
           </p:cNvPr>
@@ -9286,7 +9192,7 @@
           <a:blip>
             <a:extLst>
               <a:ext uri="{96DAC541-7B7A-43D3-8B79-37D633B846F1}">
-                <asvg:svgBlip xmlns:asvg="http://schemas.microsoft.com/office/drawing/2016/SVG/main" r:embed="rId3"/>
+                <asvg:svgBlip xmlns:asvg="http://schemas.microsoft.com/office/drawing/2016/SVG/main" r:embed="rId2"/>
               </a:ext>
             </a:extLst>
           </a:blip>
@@ -9296,18 +9202,65 @@
         </p:blipFill>
         <p:spPr>
           <a:xfrm rot="2243993">
-            <a:off x="7822728" y="812955"/>
+            <a:off x="5477771" y="5673983"/>
             <a:ext cx="914400" cy="914400"/>
           </a:xfrm>
           <a:prstGeom prst="rect">
             <a:avLst/>
           </a:prstGeom>
+        </p:spPr>
+      </p:pic>
+      <p:pic>
+        <p:nvPicPr>
+          <p:cNvPr id="2050" name="Picture 2" descr="Flowchart of the Artificial Bee Colony algorithm. | Download Scientific  Diagram">
+            <a:extLst>
+              <a:ext uri="{FF2B5EF4-FFF2-40B4-BE49-F238E27FC236}">
+                <a16:creationId xmlns:a16="http://schemas.microsoft.com/office/drawing/2014/main" id="{76ED0947-7D96-0087-2DD9-6990F89974AC}"/>
+              </a:ext>
+            </a:extLst>
+          </p:cNvPr>
+          <p:cNvPicPr>
+            <a:picLocks noChangeAspect="1" noChangeArrowheads="1"/>
+          </p:cNvPicPr>
+          <p:nvPr/>
+        </p:nvPicPr>
+        <p:blipFill>
+          <a:blip r:embed="rId3">
+            <a:extLst>
+              <a:ext uri="{28A0092B-C50C-407E-A947-70E740481C1C}">
+                <a14:useLocalDpi xmlns:a14="http://schemas.microsoft.com/office/drawing/2010/main" val="0"/>
+              </a:ext>
+            </a:extLst>
+          </a:blip>
+          <a:srcRect/>
+          <a:stretch>
+            <a:fillRect/>
+          </a:stretch>
+        </p:blipFill>
+        <p:spPr bwMode="auto">
+          <a:xfrm>
+            <a:off x="8004953" y="999068"/>
+            <a:ext cx="3993312" cy="5061945"/>
+          </a:xfrm>
+          <a:prstGeom prst="rect">
+            <a:avLst/>
+          </a:prstGeom>
+          <a:noFill/>
+          <a:extLst>
+            <a:ext uri="{909E8E84-426E-40DD-AFC4-6F175D3DCCD1}">
+              <a14:hiddenFill xmlns:a14="http://schemas.microsoft.com/office/drawing/2010/main">
+                <a:solidFill>
+                  <a:srgbClr val="FFFFFF"/>
+                </a:solidFill>
+              </a14:hiddenFill>
+            </a:ext>
+          </a:extLst>
         </p:spPr>
       </p:pic>
     </p:spTree>
     <p:extLst>
       <p:ext uri="{BB962C8B-B14F-4D97-AF65-F5344CB8AC3E}">
-        <p14:creationId xmlns:p14="http://schemas.microsoft.com/office/powerpoint/2010/main" val="1794257978"/>
+        <p14:creationId xmlns:p14="http://schemas.microsoft.com/office/powerpoint/2010/main" val="1949783446"/>
       </p:ext>
     </p:extLst>
   </p:cSld>
@@ -10524,6 +10477,24 @@
 </file>
 
 <file path=customXml/item1.xml><?xml version="1.0" encoding="utf-8"?>
+<?mso-contentType ?>
+<FormTemplates xmlns="http://schemas.microsoft.com/sharepoint/v3/contenttype/forms">
+  <Display>DocumentLibraryForm</Display>
+  <Edit>DocumentLibraryForm</Edit>
+  <New>DocumentLibraryForm</New>
+</FormTemplates>
+</file>
+
+<file path=customXml/item2.xml><?xml version="1.0" encoding="utf-8"?>
+<p:properties xmlns:p="http://schemas.microsoft.com/office/2006/metadata/properties" xmlns:xsi="http://www.w3.org/2001/XMLSchema-instance" xmlns:pc="http://schemas.microsoft.com/office/infopath/2007/PartnerControls">
+  <documentManagement>
+    <Status xmlns="71af3243-3dd4-4a8d-8c0d-dd76da1f02a5">Not started</Status>
+    <MediaServiceKeyPoints xmlns="71af3243-3dd4-4a8d-8c0d-dd76da1f02a5" xsi:nil="true"/>
+  </documentManagement>
+</p:properties>
+</file>
+
+<file path=customXml/item3.xml><?xml version="1.0" encoding="utf-8"?>
 <ct:contentTypeSchema xmlns:ct="http://schemas.microsoft.com/office/2006/metadata/contentType" xmlns:ma="http://schemas.microsoft.com/office/2006/metadata/properties/metaAttributes" ct:_="" ma:_="" ma:contentTypeName="Document" ma:contentTypeID="0x01010079F111ED35F8CC479449609E8A0923A6" ma:contentTypeVersion="12" ma:contentTypeDescription="Create a new document." ma:contentTypeScope="" ma:versionID="426e97fa315356fffbdcd9876fe988c2">
   <xsd:schema xmlns:xsd="http://www.w3.org/2001/XMLSchema" xmlns:xs="http://www.w3.org/2001/XMLSchema" xmlns:p="http://schemas.microsoft.com/office/2006/metadata/properties" xmlns:ns2="71af3243-3dd4-4a8d-8c0d-dd76da1f02a5" xmlns:ns3="16c05727-aa75-4e4a-9b5f-8a80a1165891" targetNamespace="http://schemas.microsoft.com/office/2006/metadata/properties" ma:root="true" ma:fieldsID="14b8f0def80e6d70ce3def20c90759ae" ns2:_="" ns3:_="">
     <xsd:import namespace="71af3243-3dd4-4a8d-8c0d-dd76da1f02a5"/>
@@ -10744,25 +10715,25 @@
 </ct:contentTypeSchema>
 </file>
 
-<file path=customXml/item2.xml><?xml version="1.0" encoding="utf-8"?>
-<p:properties xmlns:p="http://schemas.microsoft.com/office/2006/metadata/properties" xmlns:xsi="http://www.w3.org/2001/XMLSchema-instance" xmlns:pc="http://schemas.microsoft.com/office/infopath/2007/PartnerControls">
-  <documentManagement>
-    <Status xmlns="71af3243-3dd4-4a8d-8c0d-dd76da1f02a5">Not started</Status>
-    <MediaServiceKeyPoints xmlns="71af3243-3dd4-4a8d-8c0d-dd76da1f02a5" xsi:nil="true"/>
-  </documentManagement>
-</p:properties>
+<file path=customXml/itemProps1.xml><?xml version="1.0" encoding="utf-8"?>
+<ds:datastoreItem xmlns:ds="http://schemas.openxmlformats.org/officeDocument/2006/customXml" ds:itemID="{3149A8C3-21EC-4C35-871F-CCC7148089A3}">
+  <ds:schemaRefs>
+    <ds:schemaRef ds:uri="http://schemas.microsoft.com/sharepoint/v3/contenttype/forms"/>
+  </ds:schemaRefs>
+</ds:datastoreItem>
 </file>
 
-<file path=customXml/item3.xml><?xml version="1.0" encoding="utf-8"?>
-<?mso-contentType ?>
-<FormTemplates xmlns="http://schemas.microsoft.com/sharepoint/v3/contenttype/forms">
-  <Display>DocumentLibraryForm</Display>
-  <Edit>DocumentLibraryForm</Edit>
-  <New>DocumentLibraryForm</New>
-</FormTemplates>
+<file path=customXml/itemProps2.xml><?xml version="1.0" encoding="utf-8"?>
+<ds:datastoreItem xmlns:ds="http://schemas.openxmlformats.org/officeDocument/2006/customXml" ds:itemID="{081B53F0-FE0E-4C4C-84FF-93580062270A}">
+  <ds:schemaRefs>
+    <ds:schemaRef ds:uri="71af3243-3dd4-4a8d-8c0d-dd76da1f02a5"/>
+    <ds:schemaRef ds:uri="http://schemas.microsoft.com/office/2006/metadata/properties"/>
+    <ds:schemaRef ds:uri="http://schemas.microsoft.com/office/infopath/2007/PartnerControls"/>
+  </ds:schemaRefs>
+</ds:datastoreItem>
 </file>
 
-<file path=customXml/itemProps1.xml><?xml version="1.0" encoding="utf-8"?>
+<file path=customXml/itemProps3.xml><?xml version="1.0" encoding="utf-8"?>
 <ds:datastoreItem xmlns:ds="http://schemas.openxmlformats.org/officeDocument/2006/customXml" ds:itemID="{29D363B3-DC66-45B9-8B2A-DA220F5DD197}">
   <ds:schemaRefs>
     <ds:schemaRef ds:uri="16c05727-aa75-4e4a-9b5f-8a80a1165891"/>
@@ -10779,22 +10750,4 @@
     <ds:schemaRef ds:uri="http://www.w3.org/2001/XMLSchema"/>
   </ds:schemaRefs>
 </ds:datastoreItem>
-</file>
-
-<file path=customXml/itemProps2.xml><?xml version="1.0" encoding="utf-8"?>
-<ds:datastoreItem xmlns:ds="http://schemas.openxmlformats.org/officeDocument/2006/customXml" ds:itemID="{081B53F0-FE0E-4C4C-84FF-93580062270A}">
-  <ds:schemaRefs>
-    <ds:schemaRef ds:uri="71af3243-3dd4-4a8d-8c0d-dd76da1f02a5"/>
-    <ds:schemaRef ds:uri="http://schemas.microsoft.com/office/2006/metadata/properties"/>
-    <ds:schemaRef ds:uri="http://schemas.microsoft.com/office/infopath/2007/PartnerControls"/>
-  </ds:schemaRefs>
-</ds:datastoreItem>
-</file>
-
-<file path=customXml/itemProps3.xml><?xml version="1.0" encoding="utf-8"?>
-<ds:datastoreItem xmlns:ds="http://schemas.openxmlformats.org/officeDocument/2006/customXml" ds:itemID="{3149A8C3-21EC-4C35-871F-CCC7148089A3}">
-  <ds:schemaRefs>
-    <ds:schemaRef ds:uri="http://schemas.microsoft.com/sharepoint/v3/contenttype/forms"/>
-  </ds:schemaRefs>
-</ds:datastoreItem>
 </file>
</xml_diff>